<commit_message>
docs: ajustes en la presentacion pedidos por el cliente
- Titulo de portada: 'BTP RAP-ODATA APIs' en lugar de 'De PI/PO a APIs'.
- Release: S/4HANA 2025 en lugar de 2023, en las tres apariciones
  (subtitulo de portada, primera afirmacion y bloque del diagrama).
- Pie de pagina: queda solo 'PoC migracion de interfaces PI/PO', sin la
  marca.

Co-Authored-By: Claude Opus 5 <noreply@anthropic.com>
Claude-Session: https://claude.ai/code/session_01Ato1sxRwH266XxHueNfiXB
</commit_message>
<xml_diff>
--- a/docs/PoC-Migracion-Interfaces-PIPO.pptx
+++ b/docs/PoC-Migracion-Interfaces-PIPO.pptx
@@ -122,19 +122,19 @@
   <p:extLst>
     <p:ext uri="{521415D9-36F7-43E2-AB2F-B90AF26B5E84}">
       <p14:sectionLst xmlns:p14="http://schemas.microsoft.com/office/powerpoint/2010/main">
-        <p14:section name="Apertura" id="{779b1a2f-66cb-01fa-6591-aafd34226700}">
+        <p14:section name="Apertura" id="{aa9f0ce7-78fb-b3ab-844e-30dd31b5b4b0}">
           <p14:sldIdLst>
             <p14:sldId id="256"/>
           </p14:sldIdLst>
         </p14:section>
-        <p14:section name="Planteamiento" id="{3dc7e2bb-906b-2658-c573-4b155ba7c4d8}">
+        <p14:section name="Planteamiento" id="{78aab294-5625-5305-db9c-330e3d83a1ff}">
           <p14:sldIdLst>
             <p14:sldId id="257"/>
             <p14:sldId id="258"/>
             <p14:sldId id="259"/>
           </p14:sldIdLst>
         </p14:section>
-        <p14:section name="Componentes en S/4HANA" id="{b5a6a4b4-58d8-7a3f-dd25-a7da53a14b73}">
+        <p14:section name="Componentes en S/4HANA" id="{7c5bef3b-fcc8-fd8c-6ecc-5196395f00c9}">
           <p14:sldIdLst>
             <p14:sldId id="260"/>
             <p14:sldId id="261"/>
@@ -143,7 +143,7 @@
             <p14:sldId id="264"/>
           </p14:sldIdLst>
         </p14:section>
-        <p14:section name="Componentes en SAP BTP" id="{82208bc1-4bb8-f2c4-ffc9-bb1376585f3f}">
+        <p14:section name="Componentes en SAP BTP" id="{98ad6e56-8260-ced0-ec0e-7ad00fa3983a}">
           <p14:sldIdLst>
             <p14:sldId id="265"/>
             <p14:sldId id="266"/>
@@ -151,7 +151,7 @@
             <p14:sldId id="268"/>
           </p14:sldIdLst>
         </p14:section>
-        <p14:section name="Resultado" id="{81f5ddec-ede7-ec9b-1e9d-99f431e26e62}">
+        <p14:section name="Resultado" id="{0c7016f0-615e-ea4c-a5ab-3f5fdc66c765}">
           <p14:sldIdLst>
             <p14:sldId id="269"/>
             <p14:sldId id="270"/>
@@ -2224,7 +2224,7 @@
                   <a:srgbClr val="4A6572"/>
                 </a:solidFill>
               </a:rPr>
-              <a:t>PoC migración de interfaces PI/PO  ·  Onibex</a:t>
+              <a:t>PoC migración de interfaces PI/PO</a:t>
             </a:r>
             <a:endParaRPr lang="en-US" sz="1000" dirty="0"/>
           </a:p>
@@ -2404,7 +2404,7 @@
                   <a:srgbClr val="4A6572"/>
                 </a:solidFill>
               </a:rPr>
-              <a:t>PoC migración de interfaces PI/PO  ·  Onibex</a:t>
+              <a:t>PoC migración de interfaces PI/PO</a:t>
             </a:r>
             <a:endParaRPr lang="en-US" sz="1000" dirty="0"/>
           </a:p>
@@ -2584,7 +2584,7 @@
                   <a:srgbClr val="4A6572"/>
                 </a:solidFill>
               </a:rPr>
-              <a:t>PoC migración de interfaces PI/PO  ·  Onibex</a:t>
+              <a:t>PoC migración de interfaces PI/PO</a:t>
             </a:r>
             <a:endParaRPr lang="en-US" sz="1000" dirty="0"/>
           </a:p>
@@ -3123,7 +3123,7 @@
                   <a:schemeClr val="bg1"/>
                 </a:solidFill>
               </a:rPr>
-              <a:t>De PI/PO a APIs</a:t>
+              <a:t>BTP RAP-ODATA APIs</a:t>
             </a:r>
             <a:endParaRPr lang="en-US" sz="5400" dirty="0"/>
           </a:p>
@@ -3161,7 +3161,7 @@
                   <a:srgbClr val="9FC7C6"/>
                 </a:solidFill>
               </a:rPr>
-              <a:t>Un objeto de negocio RAP sobre S/4HANA 2023, publicado y consumido a través de SAP BTP</a:t>
+              <a:t>Un objeto de negocio RAP sobre S/4HANA 2025, publicado y consumido a través de SAP BTP</a:t>
             </a:r>
             <a:endParaRPr lang="en-US" sz="2000" dirty="0"/>
           </a:p>
@@ -6353,7 +6353,7 @@
                   <a:schemeClr val="tx1"/>
                 </a:solidFill>
               </a:rPr>
-              <a:t>Un objeto de negocio nuevo en S/4HANA 2023</a:t>
+              <a:t>Un objeto de negocio nuevo en S/4HANA 2025</a:t>
             </a:r>
             <a:endParaRPr lang="en-US" sz="1900" dirty="0"/>
           </a:p>
@@ -7889,7 +7889,7 @@
                   <a:srgbClr val="FFFFFF"/>
                 </a:solidFill>
               </a:rPr>
-              <a:t>S/4HANA 2023</a:t>
+              <a:t>S/4HANA 2025</a:t>
             </a:r>
             <a:endParaRPr lang="en-US" sz="1700" dirty="0"/>
           </a:p>

</xml_diff>